<commit_message>
auto sync: 2026-08-14 09:00
</commit_message>
<xml_diff>
--- a/journal/group_meeting/葛良晨 260806.pptx
+++ b/journal/group_meeting/葛良晨 260806.pptx
@@ -8,7 +8,7 @@
     <p:notesMasterId r:id="rId6"/>
   </p:notesMasterIdLst>
   <p:handoutMasterIdLst>
-    <p:handoutMasterId r:id="rId14"/>
+    <p:handoutMasterId r:id="rId16"/>
   </p:handoutMasterIdLst>
   <p:sldIdLst>
     <p:sldId id="257" r:id="rId3"/>
@@ -17,10 +17,12 @@
     <p:sldId id="259" r:id="rId7"/>
     <p:sldId id="265" r:id="rId8"/>
     <p:sldId id="266" r:id="rId9"/>
-    <p:sldId id="260" r:id="rId10"/>
-    <p:sldId id="263" r:id="rId11"/>
-    <p:sldId id="261" r:id="rId12"/>
-    <p:sldId id="264" r:id="rId13"/>
+    <p:sldId id="267" r:id="rId10"/>
+    <p:sldId id="268" r:id="rId11"/>
+    <p:sldId id="260" r:id="rId12"/>
+    <p:sldId id="263" r:id="rId13"/>
+    <p:sldId id="261" r:id="rId14"/>
+    <p:sldId id="264" r:id="rId15"/>
   </p:sldIdLst>
   <p:sldSz cx="12192000" cy="6858000"/>
   <p:notesSz cx="6858000" cy="9144000"/>
@@ -3859,6 +3861,259 @@
 </file>
 
 <file path=ppt/slides/slide10.xml><?xml version="1.0" encoding="utf-8"?>
+<p:sld xmlns:a="http://schemas.openxmlformats.org/drawingml/2006/main" xmlns:r="http://schemas.openxmlformats.org/officeDocument/2006/relationships" xmlns:p="http://schemas.openxmlformats.org/presentationml/2006/main">
+  <p:cSld>
+    <p:spTree>
+      <p:nvGrpSpPr>
+        <p:cNvPr id="1" name=""/>
+        <p:cNvGrpSpPr/>
+        <p:nvPr/>
+      </p:nvGrpSpPr>
+      <p:grpSpPr/>
+      <p:sp>
+        <p:nvSpPr>
+          <p:cNvPr id="4" name="文本框 3"/>
+          <p:cNvSpPr txBox="1"/>
+          <p:nvPr/>
+        </p:nvSpPr>
+        <p:spPr>
+          <a:xfrm>
+            <a:off x="356870" y="141605"/>
+            <a:ext cx="1883410" cy="368300"/>
+          </a:xfrm>
+          <a:prstGeom prst="rect">
+            <a:avLst/>
+          </a:prstGeom>
+          <a:noFill/>
+        </p:spPr>
+        <p:txBody>
+          <a:bodyPr wrap="square" rtlCol="0">
+            <a:spAutoFit/>
+          </a:bodyPr>
+          <a:p>
+            <a:r>
+              <a:rPr lang="en-US" altLang="zh-CN"/>
+              <a:t>5PI</a:t>
+            </a:r>
+            <a:r>
+              <a:rPr lang="zh-CN" altLang="en-US"/>
+              <a:t>的验证细节</a:t>
+            </a:r>
+            <a:endParaRPr lang="zh-CN" altLang="en-US"/>
+          </a:p>
+        </p:txBody>
+      </p:sp>
+      <p:pic>
+        <p:nvPicPr>
+          <p:cNvPr id="6" name="图片 5"/>
+          <p:cNvPicPr>
+            <a:picLocks noChangeAspect="1"/>
+          </p:cNvPicPr>
+          <p:nvPr/>
+        </p:nvPicPr>
+        <p:blipFill>
+          <a:blip r:embed="rId1"/>
+          <a:stretch>
+            <a:fillRect/>
+          </a:stretch>
+        </p:blipFill>
+        <p:spPr>
+          <a:xfrm>
+            <a:off x="0" y="1242695"/>
+            <a:ext cx="12192000" cy="2668270"/>
+          </a:xfrm>
+          <a:prstGeom prst="rect">
+            <a:avLst/>
+          </a:prstGeom>
+        </p:spPr>
+      </p:pic>
+      <p:pic>
+        <p:nvPicPr>
+          <p:cNvPr id="7" name="图片 6"/>
+          <p:cNvPicPr>
+            <a:picLocks noChangeAspect="1"/>
+          </p:cNvPicPr>
+          <p:nvPr/>
+        </p:nvPicPr>
+        <p:blipFill>
+          <a:blip r:embed="rId2"/>
+          <a:stretch>
+            <a:fillRect/>
+          </a:stretch>
+        </p:blipFill>
+        <p:spPr>
+          <a:xfrm>
+            <a:off x="646430" y="3979545"/>
+            <a:ext cx="4801235" cy="2878455"/>
+          </a:xfrm>
+          <a:prstGeom prst="rect">
+            <a:avLst/>
+          </a:prstGeom>
+        </p:spPr>
+      </p:pic>
+    </p:spTree>
+    <p:custDataLst>
+      <p:tags r:id="rId3"/>
+    </p:custDataLst>
+  </p:cSld>
+  <p:clrMapOvr>
+    <a:masterClrMapping/>
+  </p:clrMapOvr>
+</p:sld>
+</file>
+
+<file path=ppt/slides/slide11.xml><?xml version="1.0" encoding="utf-8"?>
+<p:sld xmlns:a="http://schemas.openxmlformats.org/drawingml/2006/main" xmlns:r="http://schemas.openxmlformats.org/officeDocument/2006/relationships" xmlns:p="http://schemas.openxmlformats.org/presentationml/2006/main">
+  <p:cSld>
+    <p:spTree>
+      <p:nvGrpSpPr>
+        <p:cNvPr id="1" name=""/>
+        <p:cNvGrpSpPr/>
+        <p:nvPr/>
+      </p:nvGrpSpPr>
+      <p:grpSpPr/>
+      <p:pic>
+        <p:nvPicPr>
+          <p:cNvPr id="4" name="图片 3"/>
+          <p:cNvPicPr>
+            <a:picLocks noChangeAspect="1"/>
+          </p:cNvPicPr>
+          <p:nvPr/>
+        </p:nvPicPr>
+        <p:blipFill>
+          <a:blip r:embed="rId1"/>
+          <a:stretch>
+            <a:fillRect/>
+          </a:stretch>
+        </p:blipFill>
+        <p:spPr>
+          <a:xfrm>
+            <a:off x="142240" y="948055"/>
+            <a:ext cx="7778750" cy="4486910"/>
+          </a:xfrm>
+          <a:prstGeom prst="rect">
+            <a:avLst/>
+          </a:prstGeom>
+        </p:spPr>
+      </p:pic>
+      <p:sp>
+        <p:nvSpPr>
+          <p:cNvPr id="5" name="文本框 4"/>
+          <p:cNvSpPr txBox="1"/>
+          <p:nvPr/>
+        </p:nvSpPr>
+        <p:spPr>
+          <a:xfrm>
+            <a:off x="0" y="0"/>
+            <a:ext cx="4064000" cy="368300"/>
+          </a:xfrm>
+          <a:prstGeom prst="rect">
+            <a:avLst/>
+          </a:prstGeom>
+          <a:noFill/>
+        </p:spPr>
+        <p:txBody>
+          <a:bodyPr wrap="square" rtlCol="0">
+            <a:spAutoFit/>
+          </a:bodyPr>
+          <a:p>
+            <a:r>
+              <a:rPr lang="en-US" altLang="zh-CN"/>
+              <a:t>9PI</a:t>
+            </a:r>
+            <a:r>
+              <a:rPr lang="zh-CN" altLang="en-US"/>
+              <a:t>的行为级模型</a:t>
+            </a:r>
+            <a:r>
+              <a:rPr lang="en-US" altLang="zh-CN"/>
+              <a:t>，</a:t>
+            </a:r>
+            <a:r>
+              <a:rPr lang="zh-CN" altLang="en-US"/>
+              <a:t>验证</a:t>
+            </a:r>
+            <a:r>
+              <a:rPr lang="zh-CN" altLang="en-US"/>
+              <a:t>细节</a:t>
+            </a:r>
+            <a:endParaRPr lang="zh-CN" altLang="en-US"/>
+          </a:p>
+        </p:txBody>
+      </p:sp>
+      <p:sp>
+        <p:nvSpPr>
+          <p:cNvPr id="6" name="文本框 5"/>
+          <p:cNvSpPr txBox="1"/>
+          <p:nvPr/>
+        </p:nvSpPr>
+        <p:spPr>
+          <a:xfrm>
+            <a:off x="8258810" y="1093470"/>
+            <a:ext cx="3255645" cy="645160"/>
+          </a:xfrm>
+          <a:prstGeom prst="rect">
+            <a:avLst/>
+          </a:prstGeom>
+          <a:noFill/>
+        </p:spPr>
+        <p:txBody>
+          <a:bodyPr wrap="square" rtlCol="0">
+            <a:spAutoFit/>
+          </a:bodyPr>
+          <a:p>
+            <a:r>
+              <a:rPr lang="en-US" altLang="zh-CN"/>
+              <a:t>PI_I_W</a:t>
+            </a:r>
+            <a:r>
+              <a:rPr lang="zh-CN" altLang="en-US"/>
+              <a:t>变化</a:t>
+            </a:r>
+            <a:r>
+              <a:rPr lang="en-US" altLang="zh-CN"/>
+              <a:t>，Ip</a:t>
+            </a:r>
+            <a:r>
+              <a:rPr lang="zh-CN" altLang="en-US"/>
+              <a:t>的相位介于</a:t>
+            </a:r>
+            <a:r>
+              <a:rPr lang="en-US" altLang="zh-CN"/>
+              <a:t>2phase</a:t>
+            </a:r>
+            <a:r>
+              <a:rPr lang="zh-CN" altLang="en-US"/>
+              <a:t>中间</a:t>
+            </a:r>
+            <a:r>
+              <a:rPr lang="en-US" altLang="zh-CN"/>
+              <a:t>，</a:t>
+            </a:r>
+            <a:r>
+              <a:rPr lang="zh-CN" altLang="en-US"/>
+              <a:t>实现插值</a:t>
+            </a:r>
+            <a:r>
+              <a:rPr lang="zh-CN" altLang="en-US"/>
+              <a:t>变化</a:t>
+            </a:r>
+            <a:endParaRPr lang="zh-CN" altLang="en-US"/>
+          </a:p>
+        </p:txBody>
+      </p:sp>
+    </p:spTree>
+    <p:custDataLst>
+      <p:tags r:id="rId2"/>
+    </p:custDataLst>
+  </p:cSld>
+  <p:clrMapOvr>
+    <a:masterClrMapping/>
+  </p:clrMapOvr>
+</p:sld>
+</file>
+
+<file path=ppt/slides/slide12.xml><?xml version="1.0" encoding="utf-8"?>
 <p:sld xmlns:a="http://schemas.openxmlformats.org/drawingml/2006/main" xmlns:r="http://schemas.openxmlformats.org/officeDocument/2006/relationships" xmlns:p="http://schemas.openxmlformats.org/presentationml/2006/main">
   <p:cSld>
     <p:spTree>
@@ -12707,7 +12962,7 @@
         </p:nvSpPr>
         <p:spPr>
           <a:xfrm>
-            <a:off x="334645" y="324485"/>
+            <a:off x="0" y="0"/>
             <a:ext cx="4064000" cy="368300"/>
           </a:xfrm>
           <a:prstGeom prst="rect">
@@ -12752,8 +13007,8 @@
         </p:blipFill>
         <p:spPr>
           <a:xfrm>
-            <a:off x="334645" y="692785"/>
-            <a:ext cx="7092315" cy="2990215"/>
+            <a:off x="0" y="273685"/>
+            <a:ext cx="6489700" cy="2736215"/>
           </a:xfrm>
           <a:prstGeom prst="rect">
             <a:avLst/>
@@ -12768,8 +13023,8 @@
         </p:nvSpPr>
         <p:spPr>
           <a:xfrm>
-            <a:off x="7567295" y="843915"/>
-            <a:ext cx="4064000" cy="368300"/>
+            <a:off x="5559425" y="329565"/>
+            <a:ext cx="2992120" cy="368300"/>
           </a:xfrm>
           <a:prstGeom prst="rect">
             <a:avLst/>
@@ -12782,22 +13037,34 @@
           </a:bodyPr>
           <a:p>
             <a:r>
-              <a:rPr lang="zh-CN" altLang="en-US"/>
+              <a:rPr lang="zh-CN" altLang="en-US">
+                <a:solidFill>
+                  <a:srgbClr val="FF0000"/>
+                </a:solidFill>
+              </a:rPr>
               <a:t>模拟输入，</a:t>
             </a:r>
             <a:r>
-              <a:rPr lang="en-US" altLang="zh-CN"/>
+              <a:rPr lang="en-US" altLang="zh-CN">
+                <a:solidFill>
+                  <a:srgbClr val="FF0000"/>
+                </a:solidFill>
+              </a:rPr>
               <a:t>64</a:t>
             </a:r>
             <a:r>
-              <a:rPr lang="zh-CN" altLang="en-US"/>
-              <a:t>路时钟的</a:t>
-            </a:r>
-            <a:r>
-              <a:rPr lang="zh-CN" altLang="en-US"/>
-              <a:t>脉冲</a:t>
-            </a:r>
-            <a:endParaRPr lang="zh-CN" altLang="en-US"/>
+              <a:rPr lang="zh-CN" altLang="en-US">
+                <a:solidFill>
+                  <a:srgbClr val="FF0000"/>
+                </a:solidFill>
+              </a:rPr>
+              <a:t>路时钟的脉冲</a:t>
+            </a:r>
+            <a:endParaRPr lang="zh-CN" altLang="en-US">
+              <a:solidFill>
+                <a:srgbClr val="FF0000"/>
+              </a:solidFill>
+            </a:endParaRPr>
           </a:p>
         </p:txBody>
       </p:sp>
@@ -12809,8 +13076,8 @@
         </p:nvSpPr>
         <p:spPr>
           <a:xfrm>
-            <a:off x="7567295" y="1687830"/>
-            <a:ext cx="4064000" cy="368300"/>
+            <a:off x="5831840" y="1257300"/>
+            <a:ext cx="2116455" cy="368300"/>
           </a:xfrm>
           <a:prstGeom prst="rect">
             <a:avLst/>
@@ -12823,18 +13090,26 @@
           </a:bodyPr>
           <a:p>
             <a:r>
-              <a:rPr lang="en-US" altLang="zh-CN"/>
+              <a:rPr lang="en-US" altLang="zh-CN">
+                <a:solidFill>
+                  <a:srgbClr val="FF0000"/>
+                </a:solidFill>
+              </a:rPr>
               <a:t>gain</a:t>
             </a:r>
             <a:r>
-              <a:rPr lang="zh-CN" altLang="en-US"/>
-              <a:t>的校准</a:t>
-            </a:r>
-            <a:r>
-              <a:rPr lang="zh-CN" altLang="en-US"/>
-              <a:t>接口</a:t>
-            </a:r>
-            <a:endParaRPr lang="zh-CN" altLang="en-US"/>
+              <a:rPr lang="zh-CN" altLang="en-US">
+                <a:solidFill>
+                  <a:srgbClr val="FF0000"/>
+                </a:solidFill>
+              </a:rPr>
+              <a:t>的校准接口</a:t>
+            </a:r>
+            <a:endParaRPr lang="zh-CN" altLang="en-US">
+              <a:solidFill>
+                <a:srgbClr val="FF0000"/>
+              </a:solidFill>
+            </a:endParaRPr>
           </a:p>
         </p:txBody>
       </p:sp>
@@ -12846,8 +13121,8 @@
         </p:nvSpPr>
         <p:spPr>
           <a:xfrm>
-            <a:off x="7567295" y="2315210"/>
-            <a:ext cx="4064000" cy="368300"/>
+            <a:off x="5831840" y="1884680"/>
+            <a:ext cx="1988820" cy="368300"/>
           </a:xfrm>
           <a:prstGeom prst="rect">
             <a:avLst/>
@@ -12860,18 +13135,26 @@
           </a:bodyPr>
           <a:p>
             <a:r>
-              <a:rPr lang="en-US" altLang="zh-CN"/>
+              <a:rPr lang="en-US" altLang="zh-CN">
+                <a:solidFill>
+                  <a:srgbClr val="FF0000"/>
+                </a:solidFill>
+              </a:rPr>
               <a:t>offset</a:t>
             </a:r>
             <a:r>
-              <a:rPr lang="zh-CN" altLang="en-US"/>
-              <a:t>的校准</a:t>
-            </a:r>
-            <a:r>
-              <a:rPr lang="zh-CN" altLang="en-US"/>
-              <a:t>接口</a:t>
-            </a:r>
-            <a:endParaRPr lang="zh-CN" altLang="en-US"/>
+              <a:rPr lang="zh-CN" altLang="en-US">
+                <a:solidFill>
+                  <a:srgbClr val="FF0000"/>
+                </a:solidFill>
+              </a:rPr>
+              <a:t>的校准接口</a:t>
+            </a:r>
+            <a:endParaRPr lang="zh-CN" altLang="en-US">
+              <a:solidFill>
+                <a:srgbClr val="FF0000"/>
+              </a:solidFill>
+            </a:endParaRPr>
           </a:p>
         </p:txBody>
       </p:sp>
@@ -12883,8 +13166,8 @@
         </p:nvSpPr>
         <p:spPr>
           <a:xfrm>
-            <a:off x="7567295" y="3226435"/>
-            <a:ext cx="4064000" cy="368300"/>
+            <a:off x="2822575" y="2641600"/>
+            <a:ext cx="753745" cy="368300"/>
           </a:xfrm>
           <a:prstGeom prst="rect">
             <a:avLst/>
@@ -12897,16 +13180,48 @@
           </a:bodyPr>
           <a:p>
             <a:r>
-              <a:rPr lang="zh-CN" altLang="en-US"/>
+              <a:rPr lang="zh-CN" altLang="en-US">
+                <a:solidFill>
+                  <a:srgbClr val="FF0000"/>
+                </a:solidFill>
+              </a:rPr>
               <a:t>输出</a:t>
             </a:r>
-            <a:endParaRPr lang="zh-CN" altLang="en-US"/>
-          </a:p>
-        </p:txBody>
-      </p:sp>
+            <a:endParaRPr lang="zh-CN" altLang="en-US">
+              <a:solidFill>
+                <a:srgbClr val="FF0000"/>
+              </a:solidFill>
+            </a:endParaRPr>
+          </a:p>
+        </p:txBody>
+      </p:sp>
+      <p:pic>
+        <p:nvPicPr>
+          <p:cNvPr id="10" name="图片 9"/>
+          <p:cNvPicPr>
+            <a:picLocks noChangeAspect="1"/>
+          </p:cNvPicPr>
+          <p:nvPr/>
+        </p:nvPicPr>
+        <p:blipFill>
+          <a:blip r:embed="rId2"/>
+          <a:stretch>
+            <a:fillRect/>
+          </a:stretch>
+        </p:blipFill>
+        <p:spPr>
+          <a:xfrm>
+            <a:off x="0" y="3009900"/>
+            <a:ext cx="6934200" cy="1892300"/>
+          </a:xfrm>
+          <a:prstGeom prst="rect">
+            <a:avLst/>
+          </a:prstGeom>
+        </p:spPr>
+      </p:pic>
     </p:spTree>
     <p:custDataLst>
-      <p:tags r:id="rId2"/>
+      <p:tags r:id="rId3"/>
     </p:custDataLst>
   </p:cSld>
   <p:clrMapOvr>
@@ -12925,54 +13240,9 @@
         <p:nvPr/>
       </p:nvGrpSpPr>
       <p:grpSpPr/>
-      <p:sp>
-        <p:nvSpPr>
-          <p:cNvPr id="4" name="文本框 3"/>
-          <p:cNvSpPr txBox="1"/>
-          <p:nvPr/>
-        </p:nvSpPr>
-        <p:spPr>
-          <a:xfrm>
-            <a:off x="0" y="0"/>
-            <a:ext cx="4064000" cy="368300"/>
-          </a:xfrm>
-          <a:prstGeom prst="rect">
-            <a:avLst/>
-          </a:prstGeom>
-          <a:noFill/>
-        </p:spPr>
-        <p:txBody>
-          <a:bodyPr wrap="square" rtlCol="0">
-            <a:spAutoFit/>
-          </a:bodyPr>
-          <a:p>
-            <a:r>
-              <a:rPr lang="en-US" altLang="zh-CN"/>
-              <a:t>9PI</a:t>
-            </a:r>
-            <a:r>
-              <a:rPr lang="zh-CN" altLang="en-US"/>
-              <a:t>的行为级模型</a:t>
-            </a:r>
-            <a:r>
-              <a:rPr lang="en-US" altLang="zh-CN"/>
-              <a:t>，</a:t>
-            </a:r>
-            <a:r>
-              <a:rPr lang="zh-CN" altLang="en-US"/>
-              <a:t>验证</a:t>
-            </a:r>
-            <a:r>
-              <a:rPr lang="zh-CN" altLang="en-US"/>
-              <a:t>细节</a:t>
-            </a:r>
-            <a:endParaRPr lang="zh-CN" altLang="en-US"/>
-          </a:p>
-        </p:txBody>
-      </p:sp>
       <p:pic>
         <p:nvPicPr>
-          <p:cNvPr id="5" name="图片 4"/>
+          <p:cNvPr id="4" name="图片 3"/>
           <p:cNvPicPr>
             <a:picLocks noChangeAspect="1"/>
           </p:cNvPicPr>
@@ -12986,8 +13256,8 @@
         </p:blipFill>
         <p:spPr>
           <a:xfrm>
-            <a:off x="78105" y="501650"/>
-            <a:ext cx="6807200" cy="5854700"/>
+            <a:off x="0" y="0"/>
+            <a:ext cx="4930140" cy="6858000"/>
           </a:xfrm>
           <a:prstGeom prst="rect">
             <a:avLst/>
@@ -12996,14 +13266,14 @@
       </p:pic>
       <p:sp>
         <p:nvSpPr>
-          <p:cNvPr id="6" name="文本框 5"/>
+          <p:cNvPr id="13" name="文本框 12"/>
           <p:cNvSpPr txBox="1"/>
           <p:nvPr/>
         </p:nvSpPr>
         <p:spPr>
           <a:xfrm>
-            <a:off x="7306945" y="885190"/>
-            <a:ext cx="4715510" cy="645160"/>
+            <a:off x="3517900" y="2613025"/>
+            <a:ext cx="3171825" cy="368300"/>
           </a:xfrm>
           <a:prstGeom prst="rect">
             <a:avLst/>
@@ -13016,47 +13286,190 @@
           </a:bodyPr>
           <a:p>
             <a:r>
-              <a:rPr lang="en-US" altLang="zh-CN"/>
-              <a:t>PI_I_MUX</a:t>
-            </a:r>
-            <a:r>
-              <a:rPr lang="zh-CN" altLang="en-US"/>
-              <a:t>变化，对应的</a:t>
-            </a:r>
-            <a:r>
-              <a:rPr lang="en-US" altLang="zh-CN"/>
-              <a:t>9PI</a:t>
-            </a:r>
-            <a:r>
-              <a:rPr lang="zh-CN" altLang="en-US"/>
-              <a:t>输出相位变化</a:t>
-            </a:r>
-            <a:r>
-              <a:rPr lang="en-US" altLang="zh-CN"/>
-              <a:t>。</a:t>
-            </a:r>
-            <a:endParaRPr lang="en-US" altLang="zh-CN"/>
-          </a:p>
-          <a:p>
-            <a:r>
-              <a:rPr lang="zh-CN" altLang="en-US"/>
-              <a:t>采样不同的</a:t>
-            </a:r>
-            <a:r>
-              <a:rPr lang="en-US" altLang="zh-CN"/>
-              <a:t>Inject </a:t>
-            </a:r>
-            <a:r>
-              <a:rPr lang="en-US" altLang="zh-CN"/>
-              <a:t>Phase</a:t>
-            </a:r>
-            <a:endParaRPr lang="en-US" altLang="zh-CN"/>
+              <a:rPr lang="en-US" altLang="zh-CN">
+                <a:solidFill>
+                  <a:srgbClr val="FF0000"/>
+                </a:solidFill>
+              </a:rPr>
+              <a:t>ADC</a:t>
+            </a:r>
+            <a:r>
+              <a:rPr lang="zh-CN" altLang="en-US">
+                <a:solidFill>
+                  <a:srgbClr val="FF0000"/>
+                </a:solidFill>
+              </a:rPr>
+              <a:t>转换过程</a:t>
+            </a:r>
+            <a:r>
+              <a:rPr lang="en-US" altLang="zh-CN">
+                <a:solidFill>
+                  <a:srgbClr val="FF0000"/>
+                </a:solidFill>
+              </a:rPr>
+              <a:t>--</a:t>
+            </a:r>
+            <a:r>
+              <a:rPr lang="zh-CN" altLang="en-US">
+                <a:solidFill>
+                  <a:srgbClr val="FF0000"/>
+                </a:solidFill>
+              </a:rPr>
+              <a:t>理论参考</a:t>
+            </a:r>
+            <a:endParaRPr lang="zh-CN" altLang="en-US">
+              <a:solidFill>
+                <a:srgbClr val="FF0000"/>
+              </a:solidFill>
+            </a:endParaRPr>
+          </a:p>
+        </p:txBody>
+      </p:sp>
+      <p:pic>
+        <p:nvPicPr>
+          <p:cNvPr id="6" name="图片 5"/>
+          <p:cNvPicPr>
+            <a:picLocks noChangeAspect="1"/>
+          </p:cNvPicPr>
+          <p:nvPr/>
+        </p:nvPicPr>
+        <p:blipFill>
+          <a:blip r:embed="rId2"/>
+          <a:stretch>
+            <a:fillRect/>
+          </a:stretch>
+        </p:blipFill>
+        <p:spPr>
+          <a:xfrm>
+            <a:off x="7757795" y="2609850"/>
+            <a:ext cx="4434205" cy="4248150"/>
+          </a:xfrm>
+          <a:prstGeom prst="rect">
+            <a:avLst/>
+          </a:prstGeom>
+        </p:spPr>
+      </p:pic>
+      <p:sp>
+        <p:nvSpPr>
+          <p:cNvPr id="7" name="文本框 6"/>
+          <p:cNvSpPr txBox="1"/>
+          <p:nvPr/>
+        </p:nvSpPr>
+        <p:spPr>
+          <a:xfrm>
+            <a:off x="2924175" y="4258310"/>
+            <a:ext cx="3171825" cy="368300"/>
+          </a:xfrm>
+          <a:prstGeom prst="rect">
+            <a:avLst/>
+          </a:prstGeom>
+          <a:noFill/>
+        </p:spPr>
+        <p:txBody>
+          <a:bodyPr wrap="square" rtlCol="0">
+            <a:spAutoFit/>
+          </a:bodyPr>
+          <a:p>
+            <a:r>
+              <a:rPr lang="en-US" altLang="zh-CN">
+                <a:solidFill>
+                  <a:srgbClr val="FF0000"/>
+                </a:solidFill>
+              </a:rPr>
+              <a:t>ADC</a:t>
+            </a:r>
+            <a:r>
+              <a:rPr lang="zh-CN" altLang="en-US">
+                <a:solidFill>
+                  <a:srgbClr val="FF0000"/>
+                </a:solidFill>
+              </a:rPr>
+              <a:t>转换过程</a:t>
+            </a:r>
+            <a:r>
+              <a:rPr lang="en-US" altLang="zh-CN">
+                <a:solidFill>
+                  <a:srgbClr val="FF0000"/>
+                </a:solidFill>
+              </a:rPr>
+              <a:t>--CDAC</a:t>
+            </a:r>
+            <a:r>
+              <a:rPr lang="zh-CN" altLang="en-US">
+                <a:solidFill>
+                  <a:srgbClr val="FF0000"/>
+                </a:solidFill>
+              </a:rPr>
+              <a:t>方式</a:t>
+            </a:r>
+            <a:endParaRPr lang="zh-CN" altLang="en-US">
+              <a:solidFill>
+                <a:srgbClr val="FF0000"/>
+              </a:solidFill>
+            </a:endParaRPr>
+          </a:p>
+        </p:txBody>
+      </p:sp>
+      <p:sp>
+        <p:nvSpPr>
+          <p:cNvPr id="9" name="文本框 8"/>
+          <p:cNvSpPr txBox="1"/>
+          <p:nvPr/>
+        </p:nvSpPr>
+        <p:spPr>
+          <a:xfrm>
+            <a:off x="7757795" y="2241550"/>
+            <a:ext cx="1756410" cy="368300"/>
+          </a:xfrm>
+          <a:prstGeom prst="rect">
+            <a:avLst/>
+          </a:prstGeom>
+          <a:noFill/>
+        </p:spPr>
+        <p:txBody>
+          <a:bodyPr wrap="square" rtlCol="0" anchor="t">
+            <a:spAutoFit/>
+          </a:bodyPr>
+          <a:p>
+            <a:r>
+              <a:rPr lang="en-US" altLang="zh-CN">
+                <a:solidFill>
+                  <a:srgbClr val="FF0000"/>
+                </a:solidFill>
+                <a:sym typeface="+mn-ea"/>
+              </a:rPr>
+              <a:t>CDAC</a:t>
+            </a:r>
+            <a:r>
+              <a:rPr lang="zh-CN" altLang="en-US">
+                <a:solidFill>
+                  <a:srgbClr val="FF0000"/>
+                </a:solidFill>
+                <a:sym typeface="+mn-ea"/>
+              </a:rPr>
+              <a:t>权重</a:t>
+            </a:r>
+            <a:r>
+              <a:rPr lang="zh-CN" altLang="en-US">
+                <a:solidFill>
+                  <a:srgbClr val="FF0000"/>
+                </a:solidFill>
+                <a:sym typeface="+mn-ea"/>
+              </a:rPr>
+              <a:t>信息</a:t>
+            </a:r>
+            <a:endParaRPr lang="zh-CN" altLang="en-US">
+              <a:solidFill>
+                <a:srgbClr val="FF0000"/>
+              </a:solidFill>
+              <a:sym typeface="+mn-ea"/>
+            </a:endParaRPr>
           </a:p>
         </p:txBody>
       </p:sp>
     </p:spTree>
     <p:custDataLst>
-      <p:tags r:id="rId2"/>
+      <p:tags r:id="rId3"/>
     </p:custDataLst>
   </p:cSld>
   <p:clrMapOvr>
@@ -13075,42 +13488,9 @@
         <p:nvPr/>
       </p:nvGrpSpPr>
       <p:grpSpPr/>
-      <p:sp>
-        <p:nvSpPr>
-          <p:cNvPr id="4" name="文本框 3"/>
-          <p:cNvSpPr txBox="1"/>
-          <p:nvPr/>
-        </p:nvSpPr>
-        <p:spPr>
-          <a:xfrm>
-            <a:off x="356870" y="141605"/>
-            <a:ext cx="1883410" cy="368300"/>
-          </a:xfrm>
-          <a:prstGeom prst="rect">
-            <a:avLst/>
-          </a:prstGeom>
-          <a:noFill/>
-        </p:spPr>
-        <p:txBody>
-          <a:bodyPr wrap="square" rtlCol="0">
-            <a:spAutoFit/>
-          </a:bodyPr>
-          <a:p>
-            <a:r>
-              <a:rPr lang="en-US" altLang="zh-CN"/>
-              <a:t>5PI</a:t>
-            </a:r>
-            <a:r>
-              <a:rPr lang="zh-CN" altLang="en-US"/>
-              <a:t>的验证细节</a:t>
-            </a:r>
-            <a:endParaRPr lang="zh-CN" altLang="en-US"/>
-          </a:p>
-        </p:txBody>
-      </p:sp>
       <p:pic>
         <p:nvPicPr>
-          <p:cNvPr id="6" name="图片 5"/>
+          <p:cNvPr id="4" name="图片 3"/>
           <p:cNvPicPr>
             <a:picLocks noChangeAspect="1"/>
           </p:cNvPicPr>
@@ -13124,8 +13504,69 @@
         </p:blipFill>
         <p:spPr>
           <a:xfrm>
-            <a:off x="0" y="1242695"/>
-            <a:ext cx="12192000" cy="2668270"/>
+            <a:off x="0" y="517525"/>
+            <a:ext cx="3783330" cy="1769745"/>
+          </a:xfrm>
+          <a:prstGeom prst="rect">
+            <a:avLst/>
+          </a:prstGeom>
+        </p:spPr>
+      </p:pic>
+      <p:sp>
+        <p:nvSpPr>
+          <p:cNvPr id="5" name="文本框 4"/>
+          <p:cNvSpPr txBox="1"/>
+          <p:nvPr/>
+        </p:nvSpPr>
+        <p:spPr>
+          <a:xfrm>
+            <a:off x="318135" y="149225"/>
+            <a:ext cx="4064000" cy="368300"/>
+          </a:xfrm>
+          <a:prstGeom prst="rect">
+            <a:avLst/>
+          </a:prstGeom>
+          <a:noFill/>
+        </p:spPr>
+        <p:txBody>
+          <a:bodyPr wrap="square" rtlCol="0">
+            <a:spAutoFit/>
+          </a:bodyPr>
+          <a:p>
+            <a:r>
+              <a:rPr lang="en-US" altLang="zh-CN"/>
+              <a:t>FFT</a:t>
+            </a:r>
+            <a:r>
+              <a:rPr lang="zh-CN" altLang="en-US"/>
+              <a:t>分析</a:t>
+            </a:r>
+            <a:r>
+              <a:rPr lang="zh-CN" altLang="en-US"/>
+              <a:t>结果</a:t>
+            </a:r>
+            <a:endParaRPr lang="zh-CN" altLang="en-US"/>
+          </a:p>
+        </p:txBody>
+      </p:sp>
+      <p:pic>
+        <p:nvPicPr>
+          <p:cNvPr id="6" name="图片 5"/>
+          <p:cNvPicPr>
+            <a:picLocks noChangeAspect="1"/>
+          </p:cNvPicPr>
+          <p:nvPr/>
+        </p:nvPicPr>
+        <p:blipFill>
+          <a:blip r:embed="rId2"/>
+          <a:stretch>
+            <a:fillRect/>
+          </a:stretch>
+        </p:blipFill>
+        <p:spPr>
+          <a:xfrm>
+            <a:off x="5334000" y="0"/>
+            <a:ext cx="6858000" cy="6858000"/>
           </a:xfrm>
           <a:prstGeom prst="rect">
             <a:avLst/>
@@ -13141,15 +13582,39 @@
           <p:nvPr/>
         </p:nvPicPr>
         <p:blipFill>
-          <a:blip r:embed="rId2"/>
+          <a:blip r:embed="rId3"/>
           <a:stretch>
             <a:fillRect/>
           </a:stretch>
         </p:blipFill>
         <p:spPr>
           <a:xfrm>
-            <a:off x="646430" y="3979545"/>
-            <a:ext cx="4801235" cy="2878455"/>
+            <a:off x="0" y="2401570"/>
+            <a:ext cx="5320030" cy="1418590"/>
+          </a:xfrm>
+          <a:prstGeom prst="rect">
+            <a:avLst/>
+          </a:prstGeom>
+        </p:spPr>
+      </p:pic>
+      <p:pic>
+        <p:nvPicPr>
+          <p:cNvPr id="8" name="图片 7"/>
+          <p:cNvPicPr>
+            <a:picLocks noChangeAspect="1"/>
+          </p:cNvPicPr>
+          <p:nvPr/>
+        </p:nvPicPr>
+        <p:blipFill>
+          <a:blip r:embed="rId4"/>
+          <a:stretch>
+            <a:fillRect/>
+          </a:stretch>
+        </p:blipFill>
+        <p:spPr>
+          <a:xfrm>
+            <a:off x="475615" y="3934460"/>
+            <a:ext cx="3906520" cy="3906520"/>
           </a:xfrm>
           <a:prstGeom prst="rect">
             <a:avLst/>
@@ -13158,7 +13623,7 @@
       </p:pic>
     </p:spTree>
     <p:custDataLst>
-      <p:tags r:id="rId3"/>
+      <p:tags r:id="rId5"/>
     </p:custDataLst>
   </p:cSld>
   <p:clrMapOvr>
@@ -13177,9 +13642,54 @@
         <p:nvPr/>
       </p:nvGrpSpPr>
       <p:grpSpPr/>
+      <p:sp>
+        <p:nvSpPr>
+          <p:cNvPr id="4" name="文本框 3"/>
+          <p:cNvSpPr txBox="1"/>
+          <p:nvPr/>
+        </p:nvSpPr>
+        <p:spPr>
+          <a:xfrm>
+            <a:off x="0" y="0"/>
+            <a:ext cx="4064000" cy="368300"/>
+          </a:xfrm>
+          <a:prstGeom prst="rect">
+            <a:avLst/>
+          </a:prstGeom>
+          <a:noFill/>
+        </p:spPr>
+        <p:txBody>
+          <a:bodyPr wrap="square" rtlCol="0">
+            <a:spAutoFit/>
+          </a:bodyPr>
+          <a:p>
+            <a:r>
+              <a:rPr lang="en-US" altLang="zh-CN"/>
+              <a:t>9PI</a:t>
+            </a:r>
+            <a:r>
+              <a:rPr lang="zh-CN" altLang="en-US"/>
+              <a:t>的行为级模型</a:t>
+            </a:r>
+            <a:r>
+              <a:rPr lang="en-US" altLang="zh-CN"/>
+              <a:t>，</a:t>
+            </a:r>
+            <a:r>
+              <a:rPr lang="zh-CN" altLang="en-US"/>
+              <a:t>验证</a:t>
+            </a:r>
+            <a:r>
+              <a:rPr lang="zh-CN" altLang="en-US"/>
+              <a:t>细节</a:t>
+            </a:r>
+            <a:endParaRPr lang="zh-CN" altLang="en-US"/>
+          </a:p>
+        </p:txBody>
+      </p:sp>
       <p:pic>
         <p:nvPicPr>
-          <p:cNvPr id="4" name="图片 3"/>
+          <p:cNvPr id="5" name="图片 4"/>
           <p:cNvPicPr>
             <a:picLocks noChangeAspect="1"/>
           </p:cNvPicPr>
@@ -13193,8 +13703,8 @@
         </p:blipFill>
         <p:spPr>
           <a:xfrm>
-            <a:off x="142240" y="948055"/>
-            <a:ext cx="7778750" cy="4486910"/>
+            <a:off x="78105" y="501650"/>
+            <a:ext cx="6807200" cy="5854700"/>
           </a:xfrm>
           <a:prstGeom prst="rect">
             <a:avLst/>
@@ -13203,14 +13713,14 @@
       </p:pic>
       <p:sp>
         <p:nvSpPr>
-          <p:cNvPr id="5" name="文本框 4"/>
+          <p:cNvPr id="6" name="文本框 5"/>
           <p:cNvSpPr txBox="1"/>
           <p:nvPr/>
         </p:nvSpPr>
         <p:spPr>
           <a:xfrm>
-            <a:off x="0" y="0"/>
-            <a:ext cx="4064000" cy="368300"/>
+            <a:off x="7306945" y="885190"/>
+            <a:ext cx="4715510" cy="645160"/>
           </a:xfrm>
           <a:prstGeom prst="rect">
             <a:avLst/>
@@ -13224,86 +13734,40 @@
           <a:p>
             <a:r>
               <a:rPr lang="en-US" altLang="zh-CN"/>
+              <a:t>PI_I_MUX</a:t>
+            </a:r>
+            <a:r>
+              <a:rPr lang="zh-CN" altLang="en-US"/>
+              <a:t>变化，对应的</a:t>
+            </a:r>
+            <a:r>
+              <a:rPr lang="en-US" altLang="zh-CN"/>
               <a:t>9PI</a:t>
             </a:r>
             <a:r>
               <a:rPr lang="zh-CN" altLang="en-US"/>
-              <a:t>的行为级模型</a:t>
+              <a:t>输出相位变化</a:t>
             </a:r>
             <a:r>
               <a:rPr lang="en-US" altLang="zh-CN"/>
-              <a:t>，</a:t>
-            </a:r>
+              <a:t>。</a:t>
+            </a:r>
+            <a:endParaRPr lang="en-US" altLang="zh-CN"/>
+          </a:p>
+          <a:p>
             <a:r>
               <a:rPr lang="zh-CN" altLang="en-US"/>
-              <a:t>验证</a:t>
-            </a:r>
-            <a:r>
-              <a:rPr lang="zh-CN" altLang="en-US"/>
-              <a:t>细节</a:t>
-            </a:r>
-            <a:endParaRPr lang="zh-CN" altLang="en-US"/>
-          </a:p>
-        </p:txBody>
-      </p:sp>
-      <p:sp>
-        <p:nvSpPr>
-          <p:cNvPr id="6" name="文本框 5"/>
-          <p:cNvSpPr txBox="1"/>
-          <p:nvPr/>
-        </p:nvSpPr>
-        <p:spPr>
-          <a:xfrm>
-            <a:off x="8258810" y="1093470"/>
-            <a:ext cx="3255645" cy="645160"/>
-          </a:xfrm>
-          <a:prstGeom prst="rect">
-            <a:avLst/>
-          </a:prstGeom>
-          <a:noFill/>
-        </p:spPr>
-        <p:txBody>
-          <a:bodyPr wrap="square" rtlCol="0">
-            <a:spAutoFit/>
-          </a:bodyPr>
-          <a:p>
+              <a:t>采样不同的</a:t>
+            </a:r>
             <a:r>
               <a:rPr lang="en-US" altLang="zh-CN"/>
-              <a:t>PI_I_W</a:t>
-            </a:r>
-            <a:r>
-              <a:rPr lang="zh-CN" altLang="en-US"/>
-              <a:t>变化</a:t>
+              <a:t>Inject </a:t>
             </a:r>
             <a:r>
               <a:rPr lang="en-US" altLang="zh-CN"/>
-              <a:t>，Ip</a:t>
-            </a:r>
-            <a:r>
-              <a:rPr lang="zh-CN" altLang="en-US"/>
-              <a:t>的相位介于</a:t>
-            </a:r>
-            <a:r>
-              <a:rPr lang="en-US" altLang="zh-CN"/>
-              <a:t>2phase</a:t>
-            </a:r>
-            <a:r>
-              <a:rPr lang="zh-CN" altLang="en-US"/>
-              <a:t>中间</a:t>
-            </a:r>
-            <a:r>
-              <a:rPr lang="en-US" altLang="zh-CN"/>
-              <a:t>，</a:t>
-            </a:r>
-            <a:r>
-              <a:rPr lang="zh-CN" altLang="en-US"/>
-              <a:t>实现插值</a:t>
-            </a:r>
-            <a:r>
-              <a:rPr lang="zh-CN" altLang="en-US"/>
-              <a:t>变化</a:t>
-            </a:r>
-            <a:endParaRPr lang="zh-CN" altLang="en-US"/>
+              <a:t>Phase</a:t>
+            </a:r>
+            <a:endParaRPr lang="en-US" altLang="zh-CN"/>
           </a:p>
         </p:txBody>
       </p:sp>
@@ -14209,6 +14673,22 @@
 </p:tagLst>
 </file>
 
+<file path=ppt/tags/tag73.xml><?xml version="1.0" encoding="utf-8"?>
+<p:tagLst xmlns:p="http://schemas.openxmlformats.org/presentationml/2006/main">
+  <p:tag name="KSO_WM_BEAUTIFY_FLAG" val="#wm#"/>
+  <p:tag name="KSO_WM_TEMPLATE_CATEGORY" val="custom"/>
+  <p:tag name="KSO_WM_TEMPLATE_INDEX" val="20205081"/>
+</p:tagLst>
+</file>
+
+<file path=ppt/tags/tag74.xml><?xml version="1.0" encoding="utf-8"?>
+<p:tagLst xmlns:p="http://schemas.openxmlformats.org/presentationml/2006/main">
+  <p:tag name="KSO_WM_BEAUTIFY_FLAG" val="#wm#"/>
+  <p:tag name="KSO_WM_TEMPLATE_CATEGORY" val="custom"/>
+  <p:tag name="KSO_WM_TEMPLATE_INDEX" val="20205081"/>
+</p:tagLst>
+</file>
+
 <file path=ppt/tags/tag8.xml><?xml version="1.0" encoding="utf-8"?>
 <p:tagLst xmlns:p="http://schemas.openxmlformats.org/presentationml/2006/main">
   <p:tag name="KSO_WM_UNIT_HIGHLIGHT" val="0"/>

</xml_diff>